<commit_message>
1. fixed errors for github build and review 2. as on 2026-10-23
</commit_message>
<xml_diff>
--- a/docs/rsn-habit-calendar-one-b-tutorial.pptx
+++ b/docs/rsn-habit-calendar-one-b-tutorial.pptx
@@ -2,52 +2,52 @@
 <file path=ppt/presentation.xml><?xml version="1.0" encoding="utf-8"?>
 <p:presentation xmlns:p="http://schemas.openxmlformats.org/presentationml/2006/main">
   <p:sldMasterIdLst>
-    <p:sldMasterId xmlns:r="http://schemas.openxmlformats.org/officeDocument/2006/relationships" id="2147483648" r:id="R1b915858f2b242ef"/>
+    <p:sldMasterId xmlns:r="http://schemas.openxmlformats.org/officeDocument/2006/relationships" id="2147483648" r:id="R152dced48de14253"/>
   </p:sldMasterIdLst>
   <p:notesMasterIdLst>
-    <p:notesMasterId xmlns:r="http://schemas.openxmlformats.org/officeDocument/2006/relationships" r:id="Re88c629a4aeb4fa9"/>
+    <p:notesMasterId xmlns:r="http://schemas.openxmlformats.org/officeDocument/2006/relationships" r:id="Rd97e88508d2043e0"/>
   </p:notesMasterIdLst>
   <p:sldIdLst>
-    <p:sldId xmlns:r="http://schemas.openxmlformats.org/officeDocument/2006/relationships" id="256" r:id="R46d49ab28f94447f"/>
-    <p:sldId xmlns:r="http://schemas.openxmlformats.org/officeDocument/2006/relationships" id="257" r:id="R2d02a801cc044834"/>
-    <p:sldId xmlns:r="http://schemas.openxmlformats.org/officeDocument/2006/relationships" id="258" r:id="Rf47fa356d2db4a03"/>
-    <p:sldId xmlns:r="http://schemas.openxmlformats.org/officeDocument/2006/relationships" id="259" r:id="R6fed8848457b476b"/>
-    <p:sldId xmlns:r="http://schemas.openxmlformats.org/officeDocument/2006/relationships" id="260" r:id="Ra2919aae6c254687"/>
-    <p:sldId xmlns:r="http://schemas.openxmlformats.org/officeDocument/2006/relationships" id="261" r:id="Rfef213b50c824086"/>
-    <p:sldId xmlns:r="http://schemas.openxmlformats.org/officeDocument/2006/relationships" id="262" r:id="R6e994778e5d047a7"/>
-    <p:sldId xmlns:r="http://schemas.openxmlformats.org/officeDocument/2006/relationships" id="263" r:id="R1fb5e4afec0c47e6"/>
-    <p:sldId xmlns:r="http://schemas.openxmlformats.org/officeDocument/2006/relationships" id="264" r:id="Re498743aa7904f81"/>
-    <p:sldId xmlns:r="http://schemas.openxmlformats.org/officeDocument/2006/relationships" id="265" r:id="R82dd6cb483f24c77"/>
-    <p:sldId xmlns:r="http://schemas.openxmlformats.org/officeDocument/2006/relationships" id="266" r:id="R399f79d7d25c4b65"/>
-    <p:sldId xmlns:r="http://schemas.openxmlformats.org/officeDocument/2006/relationships" id="267" r:id="R4e03ba6002844bcf"/>
-    <p:sldId xmlns:r="http://schemas.openxmlformats.org/officeDocument/2006/relationships" id="268" r:id="Rbd613f5d39d64cf1"/>
-    <p:sldId xmlns:r="http://schemas.openxmlformats.org/officeDocument/2006/relationships" id="269" r:id="Rdb3a440ecddc42c3"/>
-    <p:sldId xmlns:r="http://schemas.openxmlformats.org/officeDocument/2006/relationships" id="270" r:id="Ra2954da1a2ad4275"/>
-    <p:sldId xmlns:r="http://schemas.openxmlformats.org/officeDocument/2006/relationships" id="271" r:id="Rce906fcf4faf4a03"/>
-    <p:sldId xmlns:r="http://schemas.openxmlformats.org/officeDocument/2006/relationships" id="272" r:id="R12b1c828846940c9"/>
-    <p:sldId xmlns:r="http://schemas.openxmlformats.org/officeDocument/2006/relationships" id="273" r:id="R54e55bbf67cd49d5"/>
-    <p:sldId xmlns:r="http://schemas.openxmlformats.org/officeDocument/2006/relationships" id="274" r:id="R454617cd68d44b67"/>
-    <p:sldId xmlns:r="http://schemas.openxmlformats.org/officeDocument/2006/relationships" id="275" r:id="R7f7bbb7be1994afd"/>
-    <p:sldId xmlns:r="http://schemas.openxmlformats.org/officeDocument/2006/relationships" id="276" r:id="R3c7580513d874f87"/>
-    <p:sldId xmlns:r="http://schemas.openxmlformats.org/officeDocument/2006/relationships" id="277" r:id="Ra274c3679c2441c4"/>
-    <p:sldId xmlns:r="http://schemas.openxmlformats.org/officeDocument/2006/relationships" id="278" r:id="Rdd3513c5a6ce4c94"/>
-    <p:sldId xmlns:r="http://schemas.openxmlformats.org/officeDocument/2006/relationships" id="279" r:id="R5b7c94af9c2c4110"/>
-    <p:sldId xmlns:r="http://schemas.openxmlformats.org/officeDocument/2006/relationships" id="280" r:id="Rda77d291036d496d"/>
-    <p:sldId xmlns:r="http://schemas.openxmlformats.org/officeDocument/2006/relationships" id="281" r:id="R90d368969f764ca7"/>
-    <p:sldId xmlns:r="http://schemas.openxmlformats.org/officeDocument/2006/relationships" id="282" r:id="R59a017741e8f49ab"/>
-    <p:sldId xmlns:r="http://schemas.openxmlformats.org/officeDocument/2006/relationships" id="283" r:id="R36fbf4fd73bb4e78"/>
-    <p:sldId xmlns:r="http://schemas.openxmlformats.org/officeDocument/2006/relationships" id="284" r:id="R44648099c7444ac2"/>
-    <p:sldId xmlns:r="http://schemas.openxmlformats.org/officeDocument/2006/relationships" id="285" r:id="R772347a4b7264234"/>
-    <p:sldId xmlns:r="http://schemas.openxmlformats.org/officeDocument/2006/relationships" id="286" r:id="R08b3453f77ac4a22"/>
-    <p:sldId xmlns:r="http://schemas.openxmlformats.org/officeDocument/2006/relationships" id="287" r:id="R2ed35d6e0c2348ed"/>
-    <p:sldId xmlns:r="http://schemas.openxmlformats.org/officeDocument/2006/relationships" id="288" r:id="Rffbd42be72124fe0"/>
-    <p:sldId xmlns:r="http://schemas.openxmlformats.org/officeDocument/2006/relationships" id="289" r:id="R33467b45066d418b"/>
-    <p:sldId xmlns:r="http://schemas.openxmlformats.org/officeDocument/2006/relationships" id="290" r:id="R1bd7a3b441fc4311"/>
-    <p:sldId xmlns:r="http://schemas.openxmlformats.org/officeDocument/2006/relationships" id="291" r:id="Rfce5b9d04ab04b66"/>
-    <p:sldId xmlns:r="http://schemas.openxmlformats.org/officeDocument/2006/relationships" id="292" r:id="R82c0dea60bfd4d6d"/>
-    <p:sldId xmlns:r="http://schemas.openxmlformats.org/officeDocument/2006/relationships" id="293" r:id="Rd00b8d89d3c8458c"/>
-    <p:sldId xmlns:r="http://schemas.openxmlformats.org/officeDocument/2006/relationships" id="294" r:id="R6036e4f55ea3459c"/>
-    <p:sldId xmlns:r="http://schemas.openxmlformats.org/officeDocument/2006/relationships" id="295" r:id="R1731901d49eb4ada"/>
+    <p:sldId xmlns:r="http://schemas.openxmlformats.org/officeDocument/2006/relationships" id="256" r:id="R6dcdb8e70fff4e81"/>
+    <p:sldId xmlns:r="http://schemas.openxmlformats.org/officeDocument/2006/relationships" id="257" r:id="Ra9647ebe9cb546ec"/>
+    <p:sldId xmlns:r="http://schemas.openxmlformats.org/officeDocument/2006/relationships" id="258" r:id="Refd3cd6702c44f71"/>
+    <p:sldId xmlns:r="http://schemas.openxmlformats.org/officeDocument/2006/relationships" id="259" r:id="R159085ff625b48dd"/>
+    <p:sldId xmlns:r="http://schemas.openxmlformats.org/officeDocument/2006/relationships" id="260" r:id="R9a6c64faaab540b1"/>
+    <p:sldId xmlns:r="http://schemas.openxmlformats.org/officeDocument/2006/relationships" id="261" r:id="Rbef2967967dd4690"/>
+    <p:sldId xmlns:r="http://schemas.openxmlformats.org/officeDocument/2006/relationships" id="262" r:id="R168a782d8ce94619"/>
+    <p:sldId xmlns:r="http://schemas.openxmlformats.org/officeDocument/2006/relationships" id="263" r:id="Rcd389f0205b54d7c"/>
+    <p:sldId xmlns:r="http://schemas.openxmlformats.org/officeDocument/2006/relationships" id="264" r:id="R7ef902f1fc514c62"/>
+    <p:sldId xmlns:r="http://schemas.openxmlformats.org/officeDocument/2006/relationships" id="265" r:id="R0c5a1b98872d4bba"/>
+    <p:sldId xmlns:r="http://schemas.openxmlformats.org/officeDocument/2006/relationships" id="266" r:id="R8fbd0832c4974a50"/>
+    <p:sldId xmlns:r="http://schemas.openxmlformats.org/officeDocument/2006/relationships" id="267" r:id="R07f4c36b41024918"/>
+    <p:sldId xmlns:r="http://schemas.openxmlformats.org/officeDocument/2006/relationships" id="268" r:id="R079599b2bded46a5"/>
+    <p:sldId xmlns:r="http://schemas.openxmlformats.org/officeDocument/2006/relationships" id="269" r:id="Rcc9633e3f4a64b08"/>
+    <p:sldId xmlns:r="http://schemas.openxmlformats.org/officeDocument/2006/relationships" id="270" r:id="Red62422f746f4052"/>
+    <p:sldId xmlns:r="http://schemas.openxmlformats.org/officeDocument/2006/relationships" id="271" r:id="R4dc8f24d11034b13"/>
+    <p:sldId xmlns:r="http://schemas.openxmlformats.org/officeDocument/2006/relationships" id="272" r:id="Rab3b5bd7101f4b4f"/>
+    <p:sldId xmlns:r="http://schemas.openxmlformats.org/officeDocument/2006/relationships" id="273" r:id="R28a99cfb6dce465b"/>
+    <p:sldId xmlns:r="http://schemas.openxmlformats.org/officeDocument/2006/relationships" id="274" r:id="Rcdac0526c4c247b4"/>
+    <p:sldId xmlns:r="http://schemas.openxmlformats.org/officeDocument/2006/relationships" id="275" r:id="Rd6bae619ca744803"/>
+    <p:sldId xmlns:r="http://schemas.openxmlformats.org/officeDocument/2006/relationships" id="276" r:id="R96c83a46927c4cfe"/>
+    <p:sldId xmlns:r="http://schemas.openxmlformats.org/officeDocument/2006/relationships" id="277" r:id="Ra76111aa0419443b"/>
+    <p:sldId xmlns:r="http://schemas.openxmlformats.org/officeDocument/2006/relationships" id="278" r:id="Rfa08b9a37f564fb6"/>
+    <p:sldId xmlns:r="http://schemas.openxmlformats.org/officeDocument/2006/relationships" id="279" r:id="R7eefddae22cd4222"/>
+    <p:sldId xmlns:r="http://schemas.openxmlformats.org/officeDocument/2006/relationships" id="280" r:id="Rab3859ede6024c26"/>
+    <p:sldId xmlns:r="http://schemas.openxmlformats.org/officeDocument/2006/relationships" id="281" r:id="Rb7788ae4d56247a2"/>
+    <p:sldId xmlns:r="http://schemas.openxmlformats.org/officeDocument/2006/relationships" id="282" r:id="Rae246cc362454d9c"/>
+    <p:sldId xmlns:r="http://schemas.openxmlformats.org/officeDocument/2006/relationships" id="283" r:id="Rf071d91b376e465c"/>
+    <p:sldId xmlns:r="http://schemas.openxmlformats.org/officeDocument/2006/relationships" id="284" r:id="R8891eca8933a4cca"/>
+    <p:sldId xmlns:r="http://schemas.openxmlformats.org/officeDocument/2006/relationships" id="285" r:id="R595da9fdb89b473c"/>
+    <p:sldId xmlns:r="http://schemas.openxmlformats.org/officeDocument/2006/relationships" id="286" r:id="R8f28bf4c8e1449bd"/>
+    <p:sldId xmlns:r="http://schemas.openxmlformats.org/officeDocument/2006/relationships" id="287" r:id="Rdc4c0a6816884f93"/>
+    <p:sldId xmlns:r="http://schemas.openxmlformats.org/officeDocument/2006/relationships" id="288" r:id="Rf3ce7e9c88864bf5"/>
+    <p:sldId xmlns:r="http://schemas.openxmlformats.org/officeDocument/2006/relationships" id="289" r:id="Re318fdcbd1684d15"/>
+    <p:sldId xmlns:r="http://schemas.openxmlformats.org/officeDocument/2006/relationships" id="290" r:id="R9b611f7971404018"/>
+    <p:sldId xmlns:r="http://schemas.openxmlformats.org/officeDocument/2006/relationships" id="291" r:id="R2b73f9f2152c4ba7"/>
+    <p:sldId xmlns:r="http://schemas.openxmlformats.org/officeDocument/2006/relationships" id="292" r:id="R53be2d88343c457e"/>
+    <p:sldId xmlns:r="http://schemas.openxmlformats.org/officeDocument/2006/relationships" id="293" r:id="Rc7279d339aa3493d"/>
+    <p:sldId xmlns:r="http://schemas.openxmlformats.org/officeDocument/2006/relationships" id="294" r:id="R72ba3701998f4ed6"/>
+    <p:sldId xmlns:r="http://schemas.openxmlformats.org/officeDocument/2006/relationships" id="295" r:id="R95d944e1971b46f4"/>
   </p:sldIdLst>
   <p:sldSz cx="12192000" cy="6858000"/>
   <p:notesSz cx="6858000" cy="9144000"/>
@@ -486,7 +486,7 @@
           </a:p>
           <a:p xmlns:a="http://schemas.openxmlformats.org/drawingml/2006/main">
             <a:r>
-              <a:t>Plugin behaviour: version 1.1.3 source and repository documentation.</a:t>
+              <a:t>Plugin behaviour: version 1.1.4 source and repository documentation.</a:t>
             </a:r>
           </a:p>
         </p:txBody>
@@ -636,7 +636,7 @@
           </a:p>
           <a:p xmlns:a="http://schemas.openxmlformats.org/drawingml/2006/main">
             <a:r>
-              <a:t>Plugin behaviour: version 1.1.3 source and repository documentation.</a:t>
+              <a:t>Plugin behaviour: version 1.1.4 source and repository documentation.</a:t>
             </a:r>
           </a:p>
         </p:txBody>
@@ -716,7 +716,7 @@
           </a:p>
           <a:p xmlns:a="http://schemas.openxmlformats.org/drawingml/2006/main">
             <a:r>
-              <a:t>Plugin behaviour: version 1.1.3 source and repository documentation.</a:t>
+              <a:t>Plugin behaviour: version 1.1.4 source and repository documentation.</a:t>
             </a:r>
           </a:p>
         </p:txBody>
@@ -936,7 +936,7 @@
           </a:p>
           <a:p xmlns:a="http://schemas.openxmlformats.org/drawingml/2006/main">
             <a:r>
-              <a:t>Plugin behaviour: version 1.1.3 source and repository documentation.</a:t>
+              <a:t>Plugin behaviour: version 1.1.4 source and repository documentation.</a:t>
             </a:r>
           </a:p>
         </p:txBody>
@@ -1011,7 +1011,7 @@
           </a:p>
           <a:p xmlns:a="http://schemas.openxmlformats.org/drawingml/2006/main">
             <a:r>
-              <a:t>Plugin behaviour: version 1.1.3 source and repository documentation.</a:t>
+              <a:t>Plugin behaviour: version 1.1.4 source and repository documentation.</a:t>
             </a:r>
           </a:p>
         </p:txBody>
@@ -1086,7 +1086,7 @@
           </a:p>
           <a:p xmlns:a="http://schemas.openxmlformats.org/drawingml/2006/main">
             <a:r>
-              <a:t>Plugin behaviour: version 1.1.3 source and repository documentation.</a:t>
+              <a:t>Plugin behaviour: version 1.1.4 source and repository documentation.</a:t>
             </a:r>
           </a:p>
         </p:txBody>
@@ -1301,7 +1301,7 @@
           </a:p>
           <a:p xmlns:a="http://schemas.openxmlformats.org/drawingml/2006/main">
             <a:r>
-              <a:t>Plugin behaviour: version 1.1.3 source and repository documentation.</a:t>
+              <a:t>Plugin behaviour: version 1.1.4 source and repository documentation.</a:t>
             </a:r>
           </a:p>
         </p:txBody>
@@ -1516,7 +1516,7 @@
           </a:p>
           <a:p xmlns:a="http://schemas.openxmlformats.org/drawingml/2006/main">
             <a:r>
-              <a:t>Plugin behaviour: version 1.1.3 source and repository documentation.</a:t>
+              <a:t>Plugin behaviour: version 1.1.4 source and repository documentation.</a:t>
             </a:r>
           </a:p>
         </p:txBody>
@@ -1591,7 +1591,7 @@
           </a:p>
           <a:p xmlns:a="http://schemas.openxmlformats.org/drawingml/2006/main">
             <a:r>
-              <a:t>Plugin behaviour: version 1.1.3 source and repository documentation.</a:t>
+              <a:t>Plugin behaviour: version 1.1.4 source and repository documentation.</a:t>
             </a:r>
           </a:p>
         </p:txBody>
@@ -1666,7 +1666,7 @@
           </a:p>
           <a:p xmlns:a="http://schemas.openxmlformats.org/drawingml/2006/main">
             <a:r>
-              <a:t>Plugin behaviour: version 1.1.3 source and repository documentation.</a:t>
+              <a:t>Plugin behaviour: version 1.1.4 source and repository documentation.</a:t>
             </a:r>
           </a:p>
         </p:txBody>
@@ -1741,7 +1741,7 @@
           </a:p>
           <a:p xmlns:a="http://schemas.openxmlformats.org/drawingml/2006/main">
             <a:r>
-              <a:t>Plugin behaviour: version 1.1.3 source and repository documentation.</a:t>
+              <a:t>Plugin behaviour: version 1.1.4 source and repository documentation.</a:t>
             </a:r>
           </a:p>
         </p:txBody>
@@ -1816,7 +1816,7 @@
           </a:p>
           <a:p xmlns:a="http://schemas.openxmlformats.org/drawingml/2006/main">
             <a:r>
-              <a:t>Plugin behaviour: version 1.1.3 source and repository documentation.</a:t>
+              <a:t>Plugin behaviour: version 1.1.4 source and repository documentation.</a:t>
             </a:r>
           </a:p>
         </p:txBody>
@@ -1891,7 +1891,7 @@
           </a:p>
           <a:p xmlns:a="http://schemas.openxmlformats.org/drawingml/2006/main">
             <a:r>
-              <a:t>Plugin behaviour: version 1.1.3 source and repository documentation.</a:t>
+              <a:t>Plugin behaviour: version 1.1.4 source and repository documentation.</a:t>
             </a:r>
           </a:p>
         </p:txBody>
@@ -1966,7 +1966,7 @@
           </a:p>
           <a:p xmlns:a="http://schemas.openxmlformats.org/drawingml/2006/main">
             <a:r>
-              <a:t>Plugin behaviour: version 1.1.3 source and repository documentation.</a:t>
+              <a:t>Plugin behaviour: version 1.1.4 source and repository documentation.</a:t>
             </a:r>
           </a:p>
         </p:txBody>
@@ -2111,7 +2111,7 @@
           </a:p>
           <a:p xmlns:a="http://schemas.openxmlformats.org/drawingml/2006/main">
             <a:r>
-              <a:t>Plugin behaviour: version 1.1.3 source and repository documentation.</a:t>
+              <a:t>Plugin behaviour: version 1.1.4 source and repository documentation.</a:t>
             </a:r>
           </a:p>
         </p:txBody>
@@ -2256,7 +2256,7 @@
           </a:p>
           <a:p xmlns:a="http://schemas.openxmlformats.org/drawingml/2006/main">
             <a:r>
-              <a:t>Plugin behaviour: version 1.1.3 source and repository documentation.</a:t>
+              <a:t>Plugin behaviour: version 1.1.4 source and repository documentation.</a:t>
             </a:r>
           </a:p>
         </p:txBody>
@@ -2326,7 +2326,7 @@
           <a:lstStyle xmlns:a="http://schemas.openxmlformats.org/drawingml/2006/main"/>
           <a:p xmlns:a="http://schemas.openxmlformats.org/drawingml/2006/main">
             <a:r>
-              <a:t>Old ID: habit-calendar-001b. New ID: rsn-habit-calendar-one-b. Do not overwrite an existing new data.json without backing up and choosing which settings to keep. Use docs/MIGRATION-1.1.3.md. The new identity requires reinstalling, not an ordinary update in the old folder. Official rule: https://docs.obsidian.md/Reference/Manifest</a:t>
+              <a:t>From 1.1.3 the ID remains rsn-habit-calendar-one-b, so no identity migration is needed. The next two slides apply only to old-ID installations. See INSTALL-DOWNLOAD.md and MIGRATION-1.1.3.md. The optional plugin-folder color starter can be updated; do not overwrite your customized vault color file.</a:t>
             </a:r>
           </a:p>
         </p:txBody>
@@ -2546,7 +2546,7 @@
           </a:p>
           <a:p xmlns:a="http://schemas.openxmlformats.org/drawingml/2006/main">
             <a:r>
-              <a:t>Plugin behaviour: version 1.1.3 source and repository documentation.</a:t>
+              <a:t>Plugin behaviour: version 1.1.4 source and repository documentation.</a:t>
             </a:r>
           </a:p>
         </p:txBody>
@@ -2621,7 +2621,7 @@
           </a:p>
           <a:p xmlns:a="http://schemas.openxmlformats.org/drawingml/2006/main">
             <a:r>
-              <a:t>Plugin behaviour: version 1.1.3 source and repository documentation.</a:t>
+              <a:t>Plugin behaviour: version 1.1.4 source and repository documentation.</a:t>
             </a:r>
           </a:p>
         </p:txBody>
@@ -2691,7 +2691,7 @@
           <a:lstStyle xmlns:a="http://schemas.openxmlformats.org/drawingml/2006/main"/>
           <a:p xmlns:a="http://schemas.openxmlformats.org/drawingml/2006/main">
             <a:r>
-              <a:t>39 JavaScript and 11 Python helper/installer tests passed. 1.1.3 native device tests and hosted CI remain pending. The UI uses the same data engine as 1.1.2. Follow PLATFORM-TESTING.md and MIGRATION-1.1.3.md. Official testing guidance: https://docs.obsidian.md/Plugins/Getting%20started/Mobile%20development</a:t>
+              <a:t>Local Linux checks: 42 JavaScript and 11 Python tests. Native CI runners and actual device tests are separate and pending until executed. Windows Python helper tests need tzdata; CI installs it. See VALIDATION.md, PLATFORM-TESTING.md and TEST-RESULTS-TEMPLATE.md. Official guidance: https://docs.obsidian.md/Plugins/Getting%20started/Mobile%20development</a:t>
             </a:r>
           </a:p>
         </p:txBody>
@@ -2831,17 +2831,7 @@
           <a:lstStyle xmlns:a="http://schemas.openxmlformats.org/drawingml/2006/main"/>
           <a:p xmlns:a="http://schemas.openxmlformats.org/drawingml/2006/main">
             <a:r>
-              <a:t>Reference: https://docs.obsidian.md/community-directory/manage-entry . See docs/GITHUB-AND-COMMUNITY-RELEASE.md for step-by-step publication, official sources, test gates and future-release guidance.</a:t>
-            </a:r>
-          </a:p>
-          <a:p xmlns:a="http://schemas.openxmlformats.org/drawingml/2006/main">
-            <a:r>
-              <a:t>Official source: https://docs.obsidian.md/community-directory/manage-entry</a:t>
-            </a:r>
-          </a:p>
-          <a:p xmlns:a="http://schemas.openxmlformats.org/drawingml/2006/main">
-            <a:r>
-              <a:t>Plugin behaviour: version 1.1.3 source and repository documentation.</a:t>
+              <a:t>See CI-TROUBLESHOOTING.md. The ESLint deprecation warning is nonfatal. Windows cleanup EPERM appeared after the installation failure and needs separate diagnosis only if it persists after the dependency repair. Local checks do not guarantee hosted review approval. https://docs.obsidian.md/community-directory/faq</a:t>
             </a:r>
           </a:p>
         </p:txBody>
@@ -2911,7 +2901,7 @@
           <a:lstStyle xmlns:a="http://schemas.openxmlformats.org/drawingml/2006/main"/>
           <a:p xmlns:a="http://schemas.openxmlformats.org/drawingml/2006/main">
             <a:r>
-              <a:t>Browser-rendered phone viewport with mocked Obsidian APIs. This is not an actual mobile app screenshot. Native device acceptance for 1.1.3 remains pending.</a:t>
+              <a:t>Browser-rendered phone viewport with mocked Obsidian APIs. This is not an actual mobile app screenshot. Native device acceptance for 1.1.4 remains pending.</a:t>
             </a:r>
           </a:p>
         </p:txBody>
@@ -2981,7 +2971,7 @@
           <a:lstStyle xmlns:a="http://schemas.openxmlformats.org/drawingml/2006/main"/>
           <a:p xmlns:a="http://schemas.openxmlformats.org/drawingml/2006/main">
             <a:r>
-              <a:t>Version 1.1.3. Official manifest/submission documentation checked 23 October 2026. Personal habit data is excluded. Generic examples only. Exact device versions and native acceptance remain to be recorded.</a:t>
+              <a:t>Version 1.1.4. Official manifest/submission documentation checked 23 October 2026. Personal habit data is excluded. Generic examples only. Exact device versions and native acceptance remain to be recorded.</a:t>
             </a:r>
           </a:p>
         </p:txBody>
@@ -3051,7 +3041,7 @@
           <a:lstStyle xmlns:a="http://schemas.openxmlformats.org/drawingml/2006/main"/>
           <a:p xmlns:a="http://schemas.openxmlformats.org/drawingml/2006/main">
             <a:r>
-              <a:t>All targets use the same plugin bundle. Latest means stable at testing time. Record exact device, OS and Obsidian versions. 1.1.1 was reported working on Ubuntu/Android. 1.1.3 native device acceptance remains pending. The manifest retains 1.7.2 as an API floor, not a tested-device claim. Official source: https://docs.obsidian.md/Plugins/Getting%20started/Build%20a%20plugin</a:t>
+              <a:t>All targets use the same plugin bundle. Latest means stable at testing time. Record exact device, OS and Obsidian versions. 1.1.1 was reported working on Ubuntu/Android. 1.1.4 native device acceptance remains pending. The manifest retains 1.7.2 as an API floor, not a tested-device claim. Official source: https://docs.obsidian.md/Plugins/Getting%20started/Build%20a%20plugin</a:t>
             </a:r>
           </a:p>
         </p:txBody>
@@ -3121,12 +3111,12 @@
           <a:lstStyle xmlns:a="http://schemas.openxmlformats.org/drawingml/2006/main"/>
           <a:p xmlns:a="http://schemas.openxmlformats.org/drawingml/2006/main">
             <a:r>
-              <a:t>Repository: https://github.com/harharhari/rsn-habit-tracker-obsidian-plugin/releases/tag/1.1.3 . The link works only after the maintainer publishes the release and your account has access. A private repository requires authorized access. The six asset names are main.js, manifest.json, styles.css, hex-color-list.md, rsn-habit-calendar-one-b-1.1.3.zip, SHA256SUMS.</a:t>
+              <a:t>Repository: https://github.com/harharhari/rsn-habit-tracker-obsidian-plugin/releases/tag/1.1.4 . The link works only after the maintainer publishes the release and your account has access. A private repository requires authorized access. The six asset names are main.js, manifest.json, styles.css, hex-color-list.md, rsn-habit-calendar-one-b-1.1.4.zip, SHA256SUMS.</a:t>
             </a:r>
           </a:p>
           <a:p xmlns:a="http://schemas.openxmlformats.org/drawingml/2006/main">
             <a:r>
-              <a:t>Plugin behaviour: version 1.1.3 source and repository documentation.</a:t>
+              <a:t>Plugin behaviour: version 1.1.4 source and repository documentation.</a:t>
             </a:r>
           </a:p>
         </p:txBody>
@@ -3201,7 +3191,7 @@
           </a:p>
           <a:p xmlns:a="http://schemas.openxmlformats.org/drawingml/2006/main">
             <a:r>
-              <a:t>Plugin behaviour: version 1.1.3 source and repository documentation.</a:t>
+              <a:t>Plugin behaviour: version 1.1.4 source and repository documentation.</a:t>
             </a:r>
           </a:p>
         </p:txBody>
@@ -5784,12 +5774,12 @@
   </p:cSld>
   <p:clrMap bg1="lt1" tx1="dk1" bg2="lt2" tx2="dk2" accent1="accent1" accent2="accent2" accent3="accent3" accent4="accent4" accent5="accent5" accent6="accent6" hlink="hlink" folHlink="folHlink"/>
   <p:sldLayoutIdLst>
-    <p:sldLayoutId xmlns:r="http://schemas.openxmlformats.org/officeDocument/2006/relationships" id="2147483649" r:id="R291f1e3ed4de4555"/>
-    <p:sldLayoutId xmlns:r="http://schemas.openxmlformats.org/officeDocument/2006/relationships" id="2147483650" r:id="Rd428143c304f4ecf"/>
-    <p:sldLayoutId xmlns:r="http://schemas.openxmlformats.org/officeDocument/2006/relationships" id="2147483651" r:id="Rf619607815b64b81"/>
-    <p:sldLayoutId xmlns:r="http://schemas.openxmlformats.org/officeDocument/2006/relationships" id="2147483652" r:id="R7d169d6d80e04138"/>
-    <p:sldLayoutId xmlns:r="http://schemas.openxmlformats.org/officeDocument/2006/relationships" id="2147483653" r:id="R098053db37a6486a"/>
-    <p:sldLayoutId xmlns:r="http://schemas.openxmlformats.org/officeDocument/2006/relationships" id="2147483654" r:id="R9f4b2b9331184b2f"/>
+    <p:sldLayoutId xmlns:r="http://schemas.openxmlformats.org/officeDocument/2006/relationships" id="2147483649" r:id="Rfd23121779934e8a"/>
+    <p:sldLayoutId xmlns:r="http://schemas.openxmlformats.org/officeDocument/2006/relationships" id="2147483650" r:id="R22264d4451dc49be"/>
+    <p:sldLayoutId xmlns:r="http://schemas.openxmlformats.org/officeDocument/2006/relationships" id="2147483651" r:id="R84a58d1be7ec4a99"/>
+    <p:sldLayoutId xmlns:r="http://schemas.openxmlformats.org/officeDocument/2006/relationships" id="2147483652" r:id="Rf4c3bf6aeaa340b5"/>
+    <p:sldLayoutId xmlns:r="http://schemas.openxmlformats.org/officeDocument/2006/relationships" id="2147483653" r:id="R05d82f3bd38c4a46"/>
+    <p:sldLayoutId xmlns:r="http://schemas.openxmlformats.org/officeDocument/2006/relationships" id="2147483654" r:id="Rf30929855f944b86"/>
   </p:sldLayoutIdLst>
   <p:txStyles>
     <p:titleStyle>
@@ -6994,7 +6984,7 @@
                 <a:ea typeface="DejaVu Sans"/>
                 <a:cs typeface="DejaVu Sans"/>
               </a:rPr>
-              <a:t>Version 1.1.3 · harharhari · GPL-3.0-only</a:t>
+              <a:t>Version 1.1.4 · harharhari · GPL-3.0-only</a:t>
             </a:r>
           </a:p>
         </p:txBody>
@@ -7687,7 +7677,7 @@
                 <a:ea typeface="DejaVu Sans"/>
                 <a:cs typeface="DejaVu Sans"/>
               </a:rPr>
-              <a:t>3. Verify version 1.1.3. Press Ctrl+P and run Open current month.</a:t>
+              <a:t>3. Verify version 1.1.4. Press Ctrl+P and run Open current month.</a:t>
             </a:r>
           </a:p>
         </p:txBody>
@@ -8019,7 +8009,7 @@
                 <a:ea typeface="DejaVu Sans"/>
                 <a:cs typeface="DejaVu Sans"/>
               </a:rPr>
-              <a:t>rsn habit calendar one b 1.1.3</a:t>
+              <a:t>rsn habit calendar one b 1.1.4</a:t>
             </a:r>
           </a:p>
         </p:txBody>
@@ -9210,7 +9200,7 @@
                 <a:ea typeface="DejaVu Sans"/>
                 <a:cs typeface="DejaVu Sans"/>
               </a:rPr>
-              <a:t>rsn habit calendar one b 1.1.3</a:t>
+              <a:t>rsn habit calendar one b 1.1.4</a:t>
             </a:r>
           </a:p>
         </p:txBody>
@@ -10069,7 +10059,7 @@
                 <a:ea typeface="DejaVu Sans"/>
                 <a:cs typeface="DejaVu Sans"/>
               </a:rPr>
-              <a:t>3. Enable rsn habit calendar one b and verify version 1.1.3.</a:t>
+              <a:t>3. Enable rsn habit calendar one b and verify version 1.1.4.</a:t>
             </a:r>
           </a:p>
         </p:txBody>
@@ -10401,7 +10391,7 @@
                 <a:ea typeface="DejaVu Sans"/>
                 <a:cs typeface="DejaVu Sans"/>
               </a:rPr>
-              <a:t>rsn habit calendar one b 1.1.3</a:t>
+              <a:t>rsn habit calendar one b 1.1.4</a:t>
             </a:r>
           </a:p>
         </p:txBody>
@@ -11592,7 +11582,7 @@
                 <a:ea typeface="DejaVu Sans"/>
                 <a:cs typeface="DejaVu Sans"/>
               </a:rPr>
-              <a:t>rsn habit calendar one b 1.1.3</a:t>
+              <a:t>rsn habit calendar one b 1.1.4</a:t>
             </a:r>
           </a:p>
         </p:txBody>
@@ -12285,7 +12275,7 @@
                 <a:ea typeface="DejaVu Sans"/>
                 <a:cs typeface="DejaVu Sans"/>
               </a:rPr>
-              <a:t>2. Confirm version 1.1.3. Press Command+P to open the command palette.</a:t>
+              <a:t>2. Confirm version 1.1.4. Press Command+P to open the command palette.</a:t>
             </a:r>
           </a:p>
         </p:txBody>
@@ -12783,7 +12773,7 @@
                 <a:ea typeface="DejaVu Sans"/>
                 <a:cs typeface="DejaVu Sans"/>
               </a:rPr>
-              <a:t>rsn habit calendar one b 1.1.3</a:t>
+              <a:t>rsn habit calendar one b 1.1.4</a:t>
             </a:r>
           </a:p>
         </p:txBody>
@@ -13974,7 +13964,7 @@
                 <a:ea typeface="DejaVu Sans"/>
                 <a:cs typeface="DejaVu Sans"/>
               </a:rPr>
-              <a:t>rsn habit calendar one b 1.1.3</a:t>
+              <a:t>rsn habit calendar one b 1.1.4</a:t>
             </a:r>
           </a:p>
         </p:txBody>
@@ -15165,7 +15155,7 @@
                 <a:ea typeface="DejaVu Sans"/>
                 <a:cs typeface="DejaVu Sans"/>
               </a:rPr>
-              <a:t>rsn habit calendar one b 1.1.3</a:t>
+              <a:t>rsn habit calendar one b 1.1.4</a:t>
             </a:r>
           </a:p>
         </p:txBody>
@@ -16356,7 +16346,7 @@
                 <a:ea typeface="DejaVu Sans"/>
                 <a:cs typeface="DejaVu Sans"/>
               </a:rPr>
-              <a:t>rsn habit calendar one b 1.1.3</a:t>
+              <a:t>rsn habit calendar one b 1.1.4</a:t>
             </a:r>
           </a:p>
         </p:txBody>
@@ -16883,7 +16873,7 @@
                 <a:ea typeface="DejaVu Sans"/>
                 <a:cs typeface="DejaVu Sans"/>
               </a:rPr>
-              <a:t>1. Install 1.1.3 in the desktop rsn-test-vault and confirm it works.</a:t>
+              <a:t>1. Install 1.1.4 in the desktop rsn-test-vault and confirm it works.</a:t>
             </a:r>
           </a:p>
         </p:txBody>
@@ -17547,7 +17537,7 @@
                 <a:ea typeface="DejaVu Sans"/>
                 <a:cs typeface="DejaVu Sans"/>
               </a:rPr>
-              <a:t>rsn habit calendar one b 1.1.3</a:t>
+              <a:t>rsn habit calendar one b 1.1.4</a:t>
             </a:r>
           </a:p>
         </p:txBody>
@@ -18572,7 +18562,7 @@
                 <a:ea typeface="DejaVu Sans"/>
                 <a:cs typeface="DejaVu Sans"/>
               </a:rPr>
-              <a:t>4. Verify 1.1.3 and run Open current month. Expect one calendar per row, even on iPad.</a:t>
+              <a:t>4. Verify 1.1.4 and run Open current month. Expect one calendar per row, even on iPad.</a:t>
             </a:r>
           </a:p>
         </p:txBody>
@@ -18738,7 +18728,7 @@
                 <a:ea typeface="DejaVu Sans"/>
                 <a:cs typeface="DejaVu Sans"/>
               </a:rPr>
-              <a:t>rsn habit calendar one b 1.1.3</a:t>
+              <a:t>rsn habit calendar one b 1.1.4</a:t>
             </a:r>
           </a:p>
         </p:txBody>
@@ -19929,7 +19919,7 @@
                 <a:ea typeface="DejaVu Sans"/>
                 <a:cs typeface="DejaVu Sans"/>
               </a:rPr>
-              <a:t>rsn habit calendar one b 1.1.3</a:t>
+              <a:t>rsn habit calendar one b 1.1.4</a:t>
             </a:r>
           </a:p>
         </p:txBody>
@@ -21120,7 +21110,7 @@
                 <a:ea typeface="DejaVu Sans"/>
                 <a:cs typeface="DejaVu Sans"/>
               </a:rPr>
-              <a:t>rsn habit calendar one b 1.1.3</a:t>
+              <a:t>rsn habit calendar one b 1.1.4</a:t>
             </a:r>
           </a:p>
         </p:txBody>
@@ -22145,7 +22135,7 @@
                 <a:ea typeface="DejaVu Sans"/>
                 <a:cs typeface="DejaVu Sans"/>
               </a:rPr>
-              <a:t>4. Verify 1.1.3 and test persistence. A normal iOS Files app cannot reliably expose .obsidian.</a:t>
+              <a:t>4. Verify 1.1.4 and test persistence. A normal iOS Files app cannot reliably expose .obsidian.</a:t>
             </a:r>
           </a:p>
         </p:txBody>
@@ -22311,7 +22301,7 @@
                 <a:ea typeface="DejaVu Sans"/>
                 <a:cs typeface="DejaVu Sans"/>
               </a:rPr>
-              <a:t>rsn habit calendar one b 1.1.3</a:t>
+              <a:t>rsn habit calendar one b 1.1.4</a:t>
             </a:r>
           </a:p>
         </p:txBody>
@@ -23502,7 +23492,7 @@
                 <a:ea typeface="DejaVu Sans"/>
                 <a:cs typeface="DejaVu Sans"/>
               </a:rPr>
-              <a:t>rsn habit calendar one b 1.1.3</a:t>
+              <a:t>rsn habit calendar one b 1.1.4</a:t>
             </a:r>
           </a:p>
         </p:txBody>
@@ -24693,7 +24683,7 @@
                 <a:ea typeface="DejaVu Sans"/>
                 <a:cs typeface="DejaVu Sans"/>
               </a:rPr>
-              <a:t>rsn habit calendar one b 1.1.3</a:t>
+              <a:t>rsn habit calendar one b 1.1.4</a:t>
             </a:r>
           </a:p>
         </p:txBody>
@@ -25884,7 +25874,7 @@
                 <a:ea typeface="DejaVu Sans"/>
                 <a:cs typeface="DejaVu Sans"/>
               </a:rPr>
-              <a:t>rsn habit calendar one b 1.1.3</a:t>
+              <a:t>rsn habit calendar one b 1.1.4</a:t>
             </a:r>
           </a:p>
         </p:txBody>
@@ -27075,7 +27065,7 @@
                 <a:ea typeface="DejaVu Sans"/>
                 <a:cs typeface="DejaVu Sans"/>
               </a:rPr>
-              <a:t>rsn habit calendar one b 1.1.3</a:t>
+              <a:t>rsn habit calendar one b 1.1.4</a:t>
             </a:r>
           </a:p>
         </p:txBody>
@@ -28266,7 +28256,7 @@
                 <a:ea typeface="DejaVu Sans"/>
                 <a:cs typeface="DejaVu Sans"/>
               </a:rPr>
-              <a:t>rsn habit calendar one b 1.1.3</a:t>
+              <a:t>rsn habit calendar one b 1.1.4</a:t>
             </a:r>
           </a:p>
         </p:txBody>
@@ -29457,7 +29447,7 @@
                 <a:ea typeface="DejaVu Sans"/>
                 <a:cs typeface="DejaVu Sans"/>
               </a:rPr>
-              <a:t>rsn habit calendar one b 1.1.3</a:t>
+              <a:t>rsn habit calendar one b 1.1.4</a:t>
             </a:r>
           </a:p>
         </p:txBody>
@@ -30648,7 +30638,7 @@
                 <a:ea typeface="DejaVu Sans"/>
                 <a:cs typeface="DejaVu Sans"/>
               </a:rPr>
-              <a:t>rsn habit calendar one b 1.1.3</a:t>
+              <a:t>rsn habit calendar one b 1.1.4</a:t>
             </a:r>
           </a:p>
         </p:txBody>
@@ -31839,7 +31829,7 @@
                 <a:ea typeface="DejaVu Sans"/>
                 <a:cs typeface="DejaVu Sans"/>
               </a:rPr>
-              <a:t>rsn habit calendar one b 1.1.3</a:t>
+              <a:t>rsn habit calendar one b 1.1.4</a:t>
             </a:r>
           </a:p>
         </p:txBody>
@@ -32210,7 +32200,7 @@
           <p:cNvPr id="2" name="">
             <a:extLst xmlns:a="http://schemas.openxmlformats.org/drawingml/2006/main">
               <a:ext uri="{FF2B5EF4-FFF2-40B4-BE49-F238E27FC236}">
-                <a16:creationId xmlns:a16="http://schemas.microsoft.com/office/drawing/2014/main" id="{7D110BE0-B715-484A-AC65-600571C31D93}"/>
+                <a16:creationId xmlns:a16="http://schemas.microsoft.com/office/drawing/2014/main" id="{220C27CD-C447-4605-A99F-6C3AE2546841}"/>
               </a:ext>
             </a:extLst>
           </p:cNvPr>
@@ -32220,7 +32210,7 @@
           <p:nvPr/>
         </p:nvPicPr>
         <p:blipFill>
-          <a:blip xmlns:r="http://schemas.openxmlformats.org/officeDocument/2006/relationships" xmlns:a="http://schemas.openxmlformats.org/drawingml/2006/main" r:embed="R374bbc1551bd4b4d"/>
+          <a:blip xmlns:r="http://schemas.openxmlformats.org/officeDocument/2006/relationships" xmlns:a="http://schemas.openxmlformats.org/drawingml/2006/main" r:embed="Rb8fd01c2c09a4728"/>
           <a:stretch xmlns:a="http://schemas.openxmlformats.org/drawingml/2006/main"/>
         </p:blipFill>
         <p:spPr>
@@ -34083,7 +34073,7 @@
                 <a:ea typeface="DejaVu Sans"/>
                 <a:cs typeface="DejaVu Sans"/>
               </a:rPr>
-              <a:t>rsn habit calendar one b 1.1.3</a:t>
+              <a:t>rsn habit calendar one b 1.1.4</a:t>
             </a:r>
           </a:p>
         </p:txBody>
@@ -35274,7 +35264,7 @@
                 <a:ea typeface="DejaVu Sans"/>
                 <a:cs typeface="DejaVu Sans"/>
               </a:rPr>
-              <a:t>rsn habit calendar one b 1.1.3</a:t>
+              <a:t>rsn habit calendar one b 1.1.4</a:t>
             </a:r>
           </a:p>
         </p:txBody>
@@ -35635,7 +35625,7 @@
                 <a:ea typeface="DejaVu Sans"/>
                 <a:cs typeface="DejaVu Sans"/>
               </a:rPr>
-              <a:t>Migration from the old plugin ID</a:t>
+              <a:t>Upgrade to version 1.1.4</a:t>
             </a:r>
           </a:p>
         </p:txBody>
@@ -35801,7 +35791,7 @@
                 <a:ea typeface="DejaVu Sans"/>
                 <a:cs typeface="DejaVu Sans"/>
               </a:rPr>
-              <a:t>Back up the vault and finish syncing. Disable Habit Calendar 001b on every device.</a:t>
+              <a:t>From 1.1.3: keep the same plugin folder. Close Obsidian and back up the vault.</a:t>
             </a:r>
           </a:p>
         </p:txBody>
@@ -35967,7 +35957,7 @@
                 <a:ea typeface="DejaVu Sans"/>
                 <a:cs typeface="DejaVu Sans"/>
               </a:rPr>
-              <a:t>Install 1.1.3 in the new folder: .obsidian/plugins/rsn-habit-calendar-one-b/.</a:t>
+              <a:t>Replace main.js, manifest.json and styles.css with matching 1.1.4 files.</a:t>
             </a:r>
           </a:p>
         </p:txBody>
@@ -36133,7 +36123,7 @@
                 <a:ea typeface="DejaVu Sans"/>
                 <a:cs typeface="DejaVu Sans"/>
               </a:rPr>
-              <a:t>Copy the old data.json into the new folder before enabling it, if settings exist.</a:t>
+              <a:t>Preserve data.json and the entire Habit Tracker folder, including custom colors.</a:t>
             </a:r>
           </a:p>
         </p:txBody>
@@ -36299,7 +36289,7 @@
                 <a:ea typeface="DejaVu Sans"/>
                 <a:cs typeface="DejaVu Sans"/>
               </a:rPr>
-              <a:t>Keep the entire Habit Tracker folder. Its records and custom color file stay in place.</a:t>
+              <a:t>From the older habit-calendar-001b ID: follow the migration guide first.</a:t>
             </a:r>
           </a:p>
         </p:txBody>
@@ -36465,7 +36455,7 @@
                 <a:ea typeface="DejaVu Sans"/>
                 <a:cs typeface="DejaVu Sans"/>
               </a:rPr>
-              <a:t>rsn habit calendar one b 1.1.3</a:t>
+              <a:t>rsn habit calendar one b 1.1.4</a:t>
             </a:r>
           </a:p>
         </p:txBody>
@@ -36706,6 +36696,7 @@
               </a:defRPr>
             </a:defPPr>
             <a:lvl1pPr>
+              <a:buNone/>
               <a:defRPr sz="3300" b="1">
                 <a:solidFill>
                   <a:srgbClr val="153D38"/>
@@ -36716,6 +36707,7 @@
               </a:defRPr>
             </a:lvl1pPr>
             <a:lvl2pPr>
+              <a:buNone/>
               <a:defRPr sz="3300" b="1">
                 <a:solidFill>
                   <a:srgbClr val="153D38"/>
@@ -36726,6 +36718,7 @@
               </a:defRPr>
             </a:lvl2pPr>
             <a:lvl3pPr>
+              <a:buNone/>
               <a:defRPr sz="3300" b="1">
                 <a:solidFill>
                   <a:srgbClr val="153D38"/>
@@ -36736,6 +36729,7 @@
               </a:defRPr>
             </a:lvl3pPr>
             <a:lvl4pPr>
+              <a:buNone/>
               <a:defRPr sz="3300" b="1">
                 <a:solidFill>
                   <a:srgbClr val="153D38"/>
@@ -36746,6 +36740,7 @@
               </a:defRPr>
             </a:lvl4pPr>
             <a:lvl5pPr>
+              <a:buNone/>
               <a:defRPr sz="3300" b="1">
                 <a:solidFill>
                   <a:srgbClr val="153D38"/>
@@ -36756,6 +36751,7 @@
               </a:defRPr>
             </a:lvl5pPr>
             <a:lvl6pPr>
+              <a:buNone/>
               <a:defRPr sz="3300" b="1">
                 <a:solidFill>
                   <a:srgbClr val="153D38"/>
@@ -36766,6 +36762,7 @@
               </a:defRPr>
             </a:lvl6pPr>
             <a:lvl7pPr>
+              <a:buNone/>
               <a:defRPr sz="3300" b="1">
                 <a:solidFill>
                   <a:srgbClr val="153D38"/>
@@ -36776,6 +36773,7 @@
               </a:defRPr>
             </a:lvl7pPr>
             <a:lvl8pPr>
+              <a:buNone/>
               <a:defRPr sz="3300" b="1">
                 <a:solidFill>
                   <a:srgbClr val="153D38"/>
@@ -36786,6 +36784,7 @@
               </a:defRPr>
             </a:lvl8pPr>
             <a:lvl9pPr>
+              <a:buNone/>
               <a:defRPr sz="3300" b="1">
                 <a:solidFill>
                   <a:srgbClr val="153D38"/>
@@ -36798,6 +36797,7 @@
           </a:lstStyle>
           <a:p xmlns:a="http://schemas.openxmlformats.org/drawingml/2006/main">
             <a:pPr>
+              <a:buNone/>
               <a:defRPr sz="3300" b="1">
                 <a:solidFill>
                   <a:srgbClr val="153D38"/>
@@ -36862,6 +36862,7 @@
               </a:defRPr>
             </a:defPPr>
             <a:lvl1pPr>
+              <a:buNone/>
               <a:defRPr sz="2175" b="0">
                 <a:solidFill>
                   <a:srgbClr val="243344"/>
@@ -36872,6 +36873,7 @@
               </a:defRPr>
             </a:lvl1pPr>
             <a:lvl2pPr>
+              <a:buNone/>
               <a:defRPr sz="2175" b="0">
                 <a:solidFill>
                   <a:srgbClr val="243344"/>
@@ -36882,6 +36884,7 @@
               </a:defRPr>
             </a:lvl2pPr>
             <a:lvl3pPr>
+              <a:buNone/>
               <a:defRPr sz="2175" b="0">
                 <a:solidFill>
                   <a:srgbClr val="243344"/>
@@ -36892,6 +36895,7 @@
               </a:defRPr>
             </a:lvl3pPr>
             <a:lvl4pPr>
+              <a:buNone/>
               <a:defRPr sz="2175" b="0">
                 <a:solidFill>
                   <a:srgbClr val="243344"/>
@@ -36902,6 +36906,7 @@
               </a:defRPr>
             </a:lvl4pPr>
             <a:lvl5pPr>
+              <a:buNone/>
               <a:defRPr sz="2175" b="0">
                 <a:solidFill>
                   <a:srgbClr val="243344"/>
@@ -36912,6 +36917,7 @@
               </a:defRPr>
             </a:lvl5pPr>
             <a:lvl6pPr>
+              <a:buNone/>
               <a:defRPr sz="2175" b="0">
                 <a:solidFill>
                   <a:srgbClr val="243344"/>
@@ -36922,6 +36928,7 @@
               </a:defRPr>
             </a:lvl6pPr>
             <a:lvl7pPr>
+              <a:buNone/>
               <a:defRPr sz="2175" b="0">
                 <a:solidFill>
                   <a:srgbClr val="243344"/>
@@ -36932,6 +36939,7 @@
               </a:defRPr>
             </a:lvl7pPr>
             <a:lvl8pPr>
+              <a:buNone/>
               <a:defRPr sz="2175" b="0">
                 <a:solidFill>
                   <a:srgbClr val="243344"/>
@@ -36942,6 +36950,7 @@
               </a:defRPr>
             </a:lvl8pPr>
             <a:lvl9pPr>
+              <a:buNone/>
               <a:defRPr sz="2175" b="0">
                 <a:solidFill>
                   <a:srgbClr val="243344"/>
@@ -36954,6 +36963,7 @@
           </a:lstStyle>
           <a:p xmlns:a="http://schemas.openxmlformats.org/drawingml/2006/main">
             <a:pPr>
+              <a:buNone/>
               <a:defRPr sz="2175" b="0">
                 <a:solidFill>
                   <a:srgbClr val="243344"/>
@@ -36972,7 +36982,7 @@
                 <a:ea typeface="DejaVu Sans"/>
                 <a:cs typeface="DejaVu Sans"/>
               </a:rPr>
-              <a:t>Enable rsn habit calendar one b and confirm version 1.1.3. Keep the old plugin off.</a:t>
+              <a:t>Enable rsn habit calendar one b and confirm version 1.1.4. Keep the old plugin off.</a:t>
             </a:r>
           </a:p>
         </p:txBody>
@@ -37018,6 +37028,7 @@
               </a:defRPr>
             </a:defPPr>
             <a:lvl1pPr>
+              <a:buNone/>
               <a:defRPr sz="2175" b="0">
                 <a:solidFill>
                   <a:srgbClr val="243344"/>
@@ -37028,6 +37039,7 @@
               </a:defRPr>
             </a:lvl1pPr>
             <a:lvl2pPr>
+              <a:buNone/>
               <a:defRPr sz="2175" b="0">
                 <a:solidFill>
                   <a:srgbClr val="243344"/>
@@ -37038,6 +37050,7 @@
               </a:defRPr>
             </a:lvl2pPr>
             <a:lvl3pPr>
+              <a:buNone/>
               <a:defRPr sz="2175" b="0">
                 <a:solidFill>
                   <a:srgbClr val="243344"/>
@@ -37048,6 +37061,7 @@
               </a:defRPr>
             </a:lvl3pPr>
             <a:lvl4pPr>
+              <a:buNone/>
               <a:defRPr sz="2175" b="0">
                 <a:solidFill>
                   <a:srgbClr val="243344"/>
@@ -37058,6 +37072,7 @@
               </a:defRPr>
             </a:lvl4pPr>
             <a:lvl5pPr>
+              <a:buNone/>
               <a:defRPr sz="2175" b="0">
                 <a:solidFill>
                   <a:srgbClr val="243344"/>
@@ -37068,6 +37083,7 @@
               </a:defRPr>
             </a:lvl5pPr>
             <a:lvl6pPr>
+              <a:buNone/>
               <a:defRPr sz="2175" b="0">
                 <a:solidFill>
                   <a:srgbClr val="243344"/>
@@ -37078,6 +37094,7 @@
               </a:defRPr>
             </a:lvl6pPr>
             <a:lvl7pPr>
+              <a:buNone/>
               <a:defRPr sz="2175" b="0">
                 <a:solidFill>
                   <a:srgbClr val="243344"/>
@@ -37088,6 +37105,7 @@
               </a:defRPr>
             </a:lvl7pPr>
             <a:lvl8pPr>
+              <a:buNone/>
               <a:defRPr sz="2175" b="0">
                 <a:solidFill>
                   <a:srgbClr val="243344"/>
@@ -37098,6 +37116,7 @@
               </a:defRPr>
             </a:lvl8pPr>
             <a:lvl9pPr>
+              <a:buNone/>
               <a:defRPr sz="2175" b="0">
                 <a:solidFill>
                   <a:srgbClr val="243344"/>
@@ -37110,6 +37129,7 @@
           </a:lstStyle>
           <a:p xmlns:a="http://schemas.openxmlformats.org/drawingml/2006/main">
             <a:pPr>
+              <a:buNone/>
               <a:defRPr sz="2175" b="0">
                 <a:solidFill>
                   <a:srgbClr val="243344"/>
@@ -37174,6 +37194,7 @@
               </a:defRPr>
             </a:defPPr>
             <a:lvl1pPr>
+              <a:buNone/>
               <a:defRPr sz="2175" b="0">
                 <a:solidFill>
                   <a:srgbClr val="243344"/>
@@ -37184,6 +37205,7 @@
               </a:defRPr>
             </a:lvl1pPr>
             <a:lvl2pPr>
+              <a:buNone/>
               <a:defRPr sz="2175" b="0">
                 <a:solidFill>
                   <a:srgbClr val="243344"/>
@@ -37194,6 +37216,7 @@
               </a:defRPr>
             </a:lvl2pPr>
             <a:lvl3pPr>
+              <a:buNone/>
               <a:defRPr sz="2175" b="0">
                 <a:solidFill>
                   <a:srgbClr val="243344"/>
@@ -37204,6 +37227,7 @@
               </a:defRPr>
             </a:lvl3pPr>
             <a:lvl4pPr>
+              <a:buNone/>
               <a:defRPr sz="2175" b="0">
                 <a:solidFill>
                   <a:srgbClr val="243344"/>
@@ -37214,6 +37238,7 @@
               </a:defRPr>
             </a:lvl4pPr>
             <a:lvl5pPr>
+              <a:buNone/>
               <a:defRPr sz="2175" b="0">
                 <a:solidFill>
                   <a:srgbClr val="243344"/>
@@ -37224,6 +37249,7 @@
               </a:defRPr>
             </a:lvl5pPr>
             <a:lvl6pPr>
+              <a:buNone/>
               <a:defRPr sz="2175" b="0">
                 <a:solidFill>
                   <a:srgbClr val="243344"/>
@@ -37234,6 +37260,7 @@
               </a:defRPr>
             </a:lvl6pPr>
             <a:lvl7pPr>
+              <a:buNone/>
               <a:defRPr sz="2175" b="0">
                 <a:solidFill>
                   <a:srgbClr val="243344"/>
@@ -37244,6 +37271,7 @@
               </a:defRPr>
             </a:lvl7pPr>
             <a:lvl8pPr>
+              <a:buNone/>
               <a:defRPr sz="2175" b="0">
                 <a:solidFill>
                   <a:srgbClr val="243344"/>
@@ -37254,6 +37282,7 @@
               </a:defRPr>
             </a:lvl8pPr>
             <a:lvl9pPr>
+              <a:buNone/>
               <a:defRPr sz="2175" b="0">
                 <a:solidFill>
                   <a:srgbClr val="243344"/>
@@ -37266,6 +37295,7 @@
           </a:lstStyle>
           <a:p xmlns:a="http://schemas.openxmlformats.org/drawingml/2006/main">
             <a:pPr>
+              <a:buNone/>
               <a:defRPr sz="2175" b="0">
                 <a:solidFill>
                   <a:srgbClr val="243344"/>
@@ -37330,6 +37360,7 @@
               </a:defRPr>
             </a:defPPr>
             <a:lvl1pPr>
+              <a:buNone/>
               <a:defRPr sz="2175" b="0">
                 <a:solidFill>
                   <a:srgbClr val="243344"/>
@@ -37340,6 +37371,7 @@
               </a:defRPr>
             </a:lvl1pPr>
             <a:lvl2pPr>
+              <a:buNone/>
               <a:defRPr sz="2175" b="0">
                 <a:solidFill>
                   <a:srgbClr val="243344"/>
@@ -37350,6 +37382,7 @@
               </a:defRPr>
             </a:lvl2pPr>
             <a:lvl3pPr>
+              <a:buNone/>
               <a:defRPr sz="2175" b="0">
                 <a:solidFill>
                   <a:srgbClr val="243344"/>
@@ -37360,6 +37393,7 @@
               </a:defRPr>
             </a:lvl3pPr>
             <a:lvl4pPr>
+              <a:buNone/>
               <a:defRPr sz="2175" b="0">
                 <a:solidFill>
                   <a:srgbClr val="243344"/>
@@ -37370,6 +37404,7 @@
               </a:defRPr>
             </a:lvl4pPr>
             <a:lvl5pPr>
+              <a:buNone/>
               <a:defRPr sz="2175" b="0">
                 <a:solidFill>
                   <a:srgbClr val="243344"/>
@@ -37380,6 +37415,7 @@
               </a:defRPr>
             </a:lvl5pPr>
             <a:lvl6pPr>
+              <a:buNone/>
               <a:defRPr sz="2175" b="0">
                 <a:solidFill>
                   <a:srgbClr val="243344"/>
@@ -37390,6 +37426,7 @@
               </a:defRPr>
             </a:lvl6pPr>
             <a:lvl7pPr>
+              <a:buNone/>
               <a:defRPr sz="2175" b="0">
                 <a:solidFill>
                   <a:srgbClr val="243344"/>
@@ -37400,6 +37437,7 @@
               </a:defRPr>
             </a:lvl7pPr>
             <a:lvl8pPr>
+              <a:buNone/>
               <a:defRPr sz="2175" b="0">
                 <a:solidFill>
                   <a:srgbClr val="243344"/>
@@ -37410,6 +37448,7 @@
               </a:defRPr>
             </a:lvl8pPr>
             <a:lvl9pPr>
+              <a:buNone/>
               <a:defRPr sz="2175" b="0">
                 <a:solidFill>
                   <a:srgbClr val="243344"/>
@@ -37422,6 +37461,7 @@
           </a:lstStyle>
           <a:p xmlns:a="http://schemas.openxmlformats.org/drawingml/2006/main">
             <a:pPr>
+              <a:buNone/>
               <a:defRPr sz="2175" b="0">
                 <a:solidFill>
                   <a:srgbClr val="243344"/>
@@ -37486,6 +37526,7 @@
               </a:defRPr>
             </a:defPPr>
             <a:lvl1pPr>
+              <a:buNone/>
               <a:defRPr sz="1200" b="0">
                 <a:solidFill>
                   <a:srgbClr val="577068"/>
@@ -37496,6 +37537,7 @@
               </a:defRPr>
             </a:lvl1pPr>
             <a:lvl2pPr>
+              <a:buNone/>
               <a:defRPr sz="1200" b="0">
                 <a:solidFill>
                   <a:srgbClr val="577068"/>
@@ -37506,6 +37548,7 @@
               </a:defRPr>
             </a:lvl2pPr>
             <a:lvl3pPr>
+              <a:buNone/>
               <a:defRPr sz="1200" b="0">
                 <a:solidFill>
                   <a:srgbClr val="577068"/>
@@ -37516,6 +37559,7 @@
               </a:defRPr>
             </a:lvl3pPr>
             <a:lvl4pPr>
+              <a:buNone/>
               <a:defRPr sz="1200" b="0">
                 <a:solidFill>
                   <a:srgbClr val="577068"/>
@@ -37526,6 +37570,7 @@
               </a:defRPr>
             </a:lvl4pPr>
             <a:lvl5pPr>
+              <a:buNone/>
               <a:defRPr sz="1200" b="0">
                 <a:solidFill>
                   <a:srgbClr val="577068"/>
@@ -37536,6 +37581,7 @@
               </a:defRPr>
             </a:lvl5pPr>
             <a:lvl6pPr>
+              <a:buNone/>
               <a:defRPr sz="1200" b="0">
                 <a:solidFill>
                   <a:srgbClr val="577068"/>
@@ -37546,6 +37592,7 @@
               </a:defRPr>
             </a:lvl6pPr>
             <a:lvl7pPr>
+              <a:buNone/>
               <a:defRPr sz="1200" b="0">
                 <a:solidFill>
                   <a:srgbClr val="577068"/>
@@ -37556,6 +37603,7 @@
               </a:defRPr>
             </a:lvl7pPr>
             <a:lvl8pPr>
+              <a:buNone/>
               <a:defRPr sz="1200" b="0">
                 <a:solidFill>
                   <a:srgbClr val="577068"/>
@@ -37566,6 +37614,7 @@
               </a:defRPr>
             </a:lvl8pPr>
             <a:lvl9pPr>
+              <a:buNone/>
               <a:defRPr sz="1200" b="0">
                 <a:solidFill>
                   <a:srgbClr val="577068"/>
@@ -37578,6 +37627,7 @@
           </a:lstStyle>
           <a:p xmlns:a="http://schemas.openxmlformats.org/drawingml/2006/main">
             <a:pPr>
+              <a:buNone/>
               <a:defRPr sz="1200" b="0">
                 <a:solidFill>
                   <a:srgbClr val="577068"/>
@@ -37596,7 +37646,7 @@
                 <a:ea typeface="DejaVu Sans"/>
                 <a:cs typeface="DejaVu Sans"/>
               </a:rPr>
-              <a:t>rsn habit calendar one b 1.1.3</a:t>
+              <a:t>rsn habit calendar one b 1.1.4</a:t>
             </a:r>
           </a:p>
         </p:txBody>
@@ -37642,6 +37692,7 @@
               </a:defRPr>
             </a:defPPr>
             <a:lvl1pPr>
+              <a:buNone/>
               <a:defRPr sz="1350" b="0">
                 <a:solidFill>
                   <a:srgbClr val="577068"/>
@@ -37652,6 +37703,7 @@
               </a:defRPr>
             </a:lvl1pPr>
             <a:lvl2pPr>
+              <a:buNone/>
               <a:defRPr sz="1350" b="0">
                 <a:solidFill>
                   <a:srgbClr val="577068"/>
@@ -37662,6 +37714,7 @@
               </a:defRPr>
             </a:lvl2pPr>
             <a:lvl3pPr>
+              <a:buNone/>
               <a:defRPr sz="1350" b="0">
                 <a:solidFill>
                   <a:srgbClr val="577068"/>
@@ -37672,6 +37725,7 @@
               </a:defRPr>
             </a:lvl3pPr>
             <a:lvl4pPr>
+              <a:buNone/>
               <a:defRPr sz="1350" b="0">
                 <a:solidFill>
                   <a:srgbClr val="577068"/>
@@ -37682,6 +37736,7 @@
               </a:defRPr>
             </a:lvl4pPr>
             <a:lvl5pPr>
+              <a:buNone/>
               <a:defRPr sz="1350" b="0">
                 <a:solidFill>
                   <a:srgbClr val="577068"/>
@@ -37692,6 +37747,7 @@
               </a:defRPr>
             </a:lvl5pPr>
             <a:lvl6pPr>
+              <a:buNone/>
               <a:defRPr sz="1350" b="0">
                 <a:solidFill>
                   <a:srgbClr val="577068"/>
@@ -37702,6 +37758,7 @@
               </a:defRPr>
             </a:lvl6pPr>
             <a:lvl7pPr>
+              <a:buNone/>
               <a:defRPr sz="1350" b="0">
                 <a:solidFill>
                   <a:srgbClr val="577068"/>
@@ -37712,6 +37769,7 @@
               </a:defRPr>
             </a:lvl7pPr>
             <a:lvl8pPr>
+              <a:buNone/>
               <a:defRPr sz="1350" b="0">
                 <a:solidFill>
                   <a:srgbClr val="577068"/>
@@ -37722,6 +37780,7 @@
               </a:defRPr>
             </a:lvl8pPr>
             <a:lvl9pPr>
+              <a:buNone/>
               <a:defRPr sz="1350" b="0">
                 <a:solidFill>
                   <a:srgbClr val="577068"/>
@@ -37734,6 +37793,7 @@
           </a:lstStyle>
           <a:p xmlns:a="http://schemas.openxmlformats.org/drawingml/2006/main">
             <a:pPr>
+              <a:buNone/>
               <a:defRPr sz="1350" b="0">
                 <a:solidFill>
                   <a:srgbClr val="577068"/>
@@ -37827,6 +37887,7 @@
               </a:defRPr>
             </a:defPPr>
             <a:lvl1pPr>
+              <a:buNone/>
               <a:defRPr sz="3300" b="1">
                 <a:solidFill>
                   <a:srgbClr val="153D38"/>
@@ -37837,6 +37898,7 @@
               </a:defRPr>
             </a:lvl1pPr>
             <a:lvl2pPr>
+              <a:buNone/>
               <a:defRPr sz="3300" b="1">
                 <a:solidFill>
                   <a:srgbClr val="153D38"/>
@@ -37847,6 +37909,7 @@
               </a:defRPr>
             </a:lvl2pPr>
             <a:lvl3pPr>
+              <a:buNone/>
               <a:defRPr sz="3300" b="1">
                 <a:solidFill>
                   <a:srgbClr val="153D38"/>
@@ -37857,6 +37920,7 @@
               </a:defRPr>
             </a:lvl3pPr>
             <a:lvl4pPr>
+              <a:buNone/>
               <a:defRPr sz="3300" b="1">
                 <a:solidFill>
                   <a:srgbClr val="153D38"/>
@@ -37867,6 +37931,7 @@
               </a:defRPr>
             </a:lvl4pPr>
             <a:lvl5pPr>
+              <a:buNone/>
               <a:defRPr sz="3300" b="1">
                 <a:solidFill>
                   <a:srgbClr val="153D38"/>
@@ -37877,6 +37942,7 @@
               </a:defRPr>
             </a:lvl5pPr>
             <a:lvl6pPr>
+              <a:buNone/>
               <a:defRPr sz="3300" b="1">
                 <a:solidFill>
                   <a:srgbClr val="153D38"/>
@@ -37887,6 +37953,7 @@
               </a:defRPr>
             </a:lvl6pPr>
             <a:lvl7pPr>
+              <a:buNone/>
               <a:defRPr sz="3300" b="1">
                 <a:solidFill>
                   <a:srgbClr val="153D38"/>
@@ -37897,6 +37964,7 @@
               </a:defRPr>
             </a:lvl7pPr>
             <a:lvl8pPr>
+              <a:buNone/>
               <a:defRPr sz="3300" b="1">
                 <a:solidFill>
                   <a:srgbClr val="153D38"/>
@@ -37907,6 +37975,7 @@
               </a:defRPr>
             </a:lvl8pPr>
             <a:lvl9pPr>
+              <a:buNone/>
               <a:defRPr sz="3300" b="1">
                 <a:solidFill>
                   <a:srgbClr val="153D38"/>
@@ -37919,6 +37988,7 @@
           </a:lstStyle>
           <a:p xmlns:a="http://schemas.openxmlformats.org/drawingml/2006/main">
             <a:pPr>
+              <a:buNone/>
               <a:defRPr sz="3300" b="1">
                 <a:solidFill>
                   <a:srgbClr val="153D38"/>
@@ -37983,6 +38053,7 @@
               </a:defRPr>
             </a:defPPr>
             <a:lvl1pPr>
+              <a:buNone/>
               <a:defRPr sz="2175" b="0">
                 <a:solidFill>
                   <a:srgbClr val="243344"/>
@@ -37993,6 +38064,7 @@
               </a:defRPr>
             </a:lvl1pPr>
             <a:lvl2pPr>
+              <a:buNone/>
               <a:defRPr sz="2175" b="0">
                 <a:solidFill>
                   <a:srgbClr val="243344"/>
@@ -38003,6 +38075,7 @@
               </a:defRPr>
             </a:lvl2pPr>
             <a:lvl3pPr>
+              <a:buNone/>
               <a:defRPr sz="2175" b="0">
                 <a:solidFill>
                   <a:srgbClr val="243344"/>
@@ -38013,6 +38086,7 @@
               </a:defRPr>
             </a:lvl3pPr>
             <a:lvl4pPr>
+              <a:buNone/>
               <a:defRPr sz="2175" b="0">
                 <a:solidFill>
                   <a:srgbClr val="243344"/>
@@ -38023,6 +38097,7 @@
               </a:defRPr>
             </a:lvl4pPr>
             <a:lvl5pPr>
+              <a:buNone/>
               <a:defRPr sz="2175" b="0">
                 <a:solidFill>
                   <a:srgbClr val="243344"/>
@@ -38033,6 +38108,7 @@
               </a:defRPr>
             </a:lvl5pPr>
             <a:lvl6pPr>
+              <a:buNone/>
               <a:defRPr sz="2175" b="0">
                 <a:solidFill>
                   <a:srgbClr val="243344"/>
@@ -38043,6 +38119,7 @@
               </a:defRPr>
             </a:lvl6pPr>
             <a:lvl7pPr>
+              <a:buNone/>
               <a:defRPr sz="2175" b="0">
                 <a:solidFill>
                   <a:srgbClr val="243344"/>
@@ -38053,6 +38130,7 @@
               </a:defRPr>
             </a:lvl7pPr>
             <a:lvl8pPr>
+              <a:buNone/>
               <a:defRPr sz="2175" b="0">
                 <a:solidFill>
                   <a:srgbClr val="243344"/>
@@ -38063,6 +38141,7 @@
               </a:defRPr>
             </a:lvl8pPr>
             <a:lvl9pPr>
+              <a:buNone/>
               <a:defRPr sz="2175" b="0">
                 <a:solidFill>
                   <a:srgbClr val="243344"/>
@@ -38075,6 +38154,7 @@
           </a:lstStyle>
           <a:p xmlns:a="http://schemas.openxmlformats.org/drawingml/2006/main">
             <a:pPr>
+              <a:buNone/>
               <a:defRPr sz="2175" b="0">
                 <a:solidFill>
                   <a:srgbClr val="243344"/>
@@ -38139,6 +38219,7 @@
               </a:defRPr>
             </a:defPPr>
             <a:lvl1pPr>
+              <a:buNone/>
               <a:defRPr sz="2175" b="0">
                 <a:solidFill>
                   <a:srgbClr val="243344"/>
@@ -38149,6 +38230,7 @@
               </a:defRPr>
             </a:lvl1pPr>
             <a:lvl2pPr>
+              <a:buNone/>
               <a:defRPr sz="2175" b="0">
                 <a:solidFill>
                   <a:srgbClr val="243344"/>
@@ -38159,6 +38241,7 @@
               </a:defRPr>
             </a:lvl2pPr>
             <a:lvl3pPr>
+              <a:buNone/>
               <a:defRPr sz="2175" b="0">
                 <a:solidFill>
                   <a:srgbClr val="243344"/>
@@ -38169,6 +38252,7 @@
               </a:defRPr>
             </a:lvl3pPr>
             <a:lvl4pPr>
+              <a:buNone/>
               <a:defRPr sz="2175" b="0">
                 <a:solidFill>
                   <a:srgbClr val="243344"/>
@@ -38179,6 +38263,7 @@
               </a:defRPr>
             </a:lvl4pPr>
             <a:lvl5pPr>
+              <a:buNone/>
               <a:defRPr sz="2175" b="0">
                 <a:solidFill>
                   <a:srgbClr val="243344"/>
@@ -38189,6 +38274,7 @@
               </a:defRPr>
             </a:lvl5pPr>
             <a:lvl6pPr>
+              <a:buNone/>
               <a:defRPr sz="2175" b="0">
                 <a:solidFill>
                   <a:srgbClr val="243344"/>
@@ -38199,6 +38285,7 @@
               </a:defRPr>
             </a:lvl6pPr>
             <a:lvl7pPr>
+              <a:buNone/>
               <a:defRPr sz="2175" b="0">
                 <a:solidFill>
                   <a:srgbClr val="243344"/>
@@ -38209,6 +38296,7 @@
               </a:defRPr>
             </a:lvl7pPr>
             <a:lvl8pPr>
+              <a:buNone/>
               <a:defRPr sz="2175" b="0">
                 <a:solidFill>
                   <a:srgbClr val="243344"/>
@@ -38219,6 +38307,7 @@
               </a:defRPr>
             </a:lvl8pPr>
             <a:lvl9pPr>
+              <a:buNone/>
               <a:defRPr sz="2175" b="0">
                 <a:solidFill>
                   <a:srgbClr val="243344"/>
@@ -38231,6 +38320,7 @@
           </a:lstStyle>
           <a:p xmlns:a="http://schemas.openxmlformats.org/drawingml/2006/main">
             <a:pPr>
+              <a:buNone/>
               <a:defRPr sz="2175" b="0">
                 <a:solidFill>
                   <a:srgbClr val="243344"/>
@@ -38295,6 +38385,7 @@
               </a:defRPr>
             </a:defPPr>
             <a:lvl1pPr>
+              <a:buNone/>
               <a:defRPr sz="2175" b="0">
                 <a:solidFill>
                   <a:srgbClr val="243344"/>
@@ -38305,6 +38396,7 @@
               </a:defRPr>
             </a:lvl1pPr>
             <a:lvl2pPr>
+              <a:buNone/>
               <a:defRPr sz="2175" b="0">
                 <a:solidFill>
                   <a:srgbClr val="243344"/>
@@ -38315,6 +38407,7 @@
               </a:defRPr>
             </a:lvl2pPr>
             <a:lvl3pPr>
+              <a:buNone/>
               <a:defRPr sz="2175" b="0">
                 <a:solidFill>
                   <a:srgbClr val="243344"/>
@@ -38325,6 +38418,7 @@
               </a:defRPr>
             </a:lvl3pPr>
             <a:lvl4pPr>
+              <a:buNone/>
               <a:defRPr sz="2175" b="0">
                 <a:solidFill>
                   <a:srgbClr val="243344"/>
@@ -38335,6 +38429,7 @@
               </a:defRPr>
             </a:lvl4pPr>
             <a:lvl5pPr>
+              <a:buNone/>
               <a:defRPr sz="2175" b="0">
                 <a:solidFill>
                   <a:srgbClr val="243344"/>
@@ -38345,6 +38440,7 @@
               </a:defRPr>
             </a:lvl5pPr>
             <a:lvl6pPr>
+              <a:buNone/>
               <a:defRPr sz="2175" b="0">
                 <a:solidFill>
                   <a:srgbClr val="243344"/>
@@ -38355,6 +38451,7 @@
               </a:defRPr>
             </a:lvl6pPr>
             <a:lvl7pPr>
+              <a:buNone/>
               <a:defRPr sz="2175" b="0">
                 <a:solidFill>
                   <a:srgbClr val="243344"/>
@@ -38365,6 +38462,7 @@
               </a:defRPr>
             </a:lvl7pPr>
             <a:lvl8pPr>
+              <a:buNone/>
               <a:defRPr sz="2175" b="0">
                 <a:solidFill>
                   <a:srgbClr val="243344"/>
@@ -38375,6 +38473,7 @@
               </a:defRPr>
             </a:lvl8pPr>
             <a:lvl9pPr>
+              <a:buNone/>
               <a:defRPr sz="2175" b="0">
                 <a:solidFill>
                   <a:srgbClr val="243344"/>
@@ -38387,6 +38486,7 @@
           </a:lstStyle>
           <a:p xmlns:a="http://schemas.openxmlformats.org/drawingml/2006/main">
             <a:pPr>
+              <a:buNone/>
               <a:defRPr sz="2175" b="0">
                 <a:solidFill>
                   <a:srgbClr val="243344"/>
@@ -38405,7 +38505,7 @@
                 <a:ea typeface="DejaVu Sans"/>
                 <a:cs typeface="DejaVu Sans"/>
               </a:rPr>
-              <a:t>On each device, wait for transfer, restart, and verify the old plugin is off and 1.1.3 is on.</a:t>
+              <a:t>On each device, wait for transfer, restart, and verify the old plugin is off and 1.1.4 is on.</a:t>
             </a:r>
           </a:p>
         </p:txBody>
@@ -38451,6 +38551,7 @@
               </a:defRPr>
             </a:defPPr>
             <a:lvl1pPr>
+              <a:buNone/>
               <a:defRPr sz="2175" b="0">
                 <a:solidFill>
                   <a:srgbClr val="243344"/>
@@ -38461,6 +38562,7 @@
               </a:defRPr>
             </a:lvl1pPr>
             <a:lvl2pPr>
+              <a:buNone/>
               <a:defRPr sz="2175" b="0">
                 <a:solidFill>
                   <a:srgbClr val="243344"/>
@@ -38471,6 +38573,7 @@
               </a:defRPr>
             </a:lvl2pPr>
             <a:lvl3pPr>
+              <a:buNone/>
               <a:defRPr sz="2175" b="0">
                 <a:solidFill>
                   <a:srgbClr val="243344"/>
@@ -38481,6 +38584,7 @@
               </a:defRPr>
             </a:lvl3pPr>
             <a:lvl4pPr>
+              <a:buNone/>
               <a:defRPr sz="2175" b="0">
                 <a:solidFill>
                   <a:srgbClr val="243344"/>
@@ -38491,6 +38595,7 @@
               </a:defRPr>
             </a:lvl4pPr>
             <a:lvl5pPr>
+              <a:buNone/>
               <a:defRPr sz="2175" b="0">
                 <a:solidFill>
                   <a:srgbClr val="243344"/>
@@ -38501,6 +38606,7 @@
               </a:defRPr>
             </a:lvl5pPr>
             <a:lvl6pPr>
+              <a:buNone/>
               <a:defRPr sz="2175" b="0">
                 <a:solidFill>
                   <a:srgbClr val="243344"/>
@@ -38511,6 +38617,7 @@
               </a:defRPr>
             </a:lvl6pPr>
             <a:lvl7pPr>
+              <a:buNone/>
               <a:defRPr sz="2175" b="0">
                 <a:solidFill>
                   <a:srgbClr val="243344"/>
@@ -38521,6 +38628,7 @@
               </a:defRPr>
             </a:lvl7pPr>
             <a:lvl8pPr>
+              <a:buNone/>
               <a:defRPr sz="2175" b="0">
                 <a:solidFill>
                   <a:srgbClr val="243344"/>
@@ -38531,6 +38639,7 @@
               </a:defRPr>
             </a:lvl8pPr>
             <a:lvl9pPr>
+              <a:buNone/>
               <a:defRPr sz="2175" b="0">
                 <a:solidFill>
                   <a:srgbClr val="243344"/>
@@ -38543,6 +38652,7 @@
           </a:lstStyle>
           <a:p xmlns:a="http://schemas.openxmlformats.org/drawingml/2006/main">
             <a:pPr>
+              <a:buNone/>
               <a:defRPr sz="2175" b="0">
                 <a:solidFill>
                   <a:srgbClr val="243344"/>
@@ -38607,6 +38717,7 @@
               </a:defRPr>
             </a:defPPr>
             <a:lvl1pPr>
+              <a:buNone/>
               <a:defRPr sz="1200" b="0">
                 <a:solidFill>
                   <a:srgbClr val="577068"/>
@@ -38617,6 +38728,7 @@
               </a:defRPr>
             </a:lvl1pPr>
             <a:lvl2pPr>
+              <a:buNone/>
               <a:defRPr sz="1200" b="0">
                 <a:solidFill>
                   <a:srgbClr val="577068"/>
@@ -38627,6 +38739,7 @@
               </a:defRPr>
             </a:lvl2pPr>
             <a:lvl3pPr>
+              <a:buNone/>
               <a:defRPr sz="1200" b="0">
                 <a:solidFill>
                   <a:srgbClr val="577068"/>
@@ -38637,6 +38750,7 @@
               </a:defRPr>
             </a:lvl3pPr>
             <a:lvl4pPr>
+              <a:buNone/>
               <a:defRPr sz="1200" b="0">
                 <a:solidFill>
                   <a:srgbClr val="577068"/>
@@ -38647,6 +38761,7 @@
               </a:defRPr>
             </a:lvl4pPr>
             <a:lvl5pPr>
+              <a:buNone/>
               <a:defRPr sz="1200" b="0">
                 <a:solidFill>
                   <a:srgbClr val="577068"/>
@@ -38657,6 +38772,7 @@
               </a:defRPr>
             </a:lvl5pPr>
             <a:lvl6pPr>
+              <a:buNone/>
               <a:defRPr sz="1200" b="0">
                 <a:solidFill>
                   <a:srgbClr val="577068"/>
@@ -38667,6 +38783,7 @@
               </a:defRPr>
             </a:lvl6pPr>
             <a:lvl7pPr>
+              <a:buNone/>
               <a:defRPr sz="1200" b="0">
                 <a:solidFill>
                   <a:srgbClr val="577068"/>
@@ -38677,6 +38794,7 @@
               </a:defRPr>
             </a:lvl7pPr>
             <a:lvl8pPr>
+              <a:buNone/>
               <a:defRPr sz="1200" b="0">
                 <a:solidFill>
                   <a:srgbClr val="577068"/>
@@ -38687,6 +38805,7 @@
               </a:defRPr>
             </a:lvl8pPr>
             <a:lvl9pPr>
+              <a:buNone/>
               <a:defRPr sz="1200" b="0">
                 <a:solidFill>
                   <a:srgbClr val="577068"/>
@@ -38699,6 +38818,7 @@
           </a:lstStyle>
           <a:p xmlns:a="http://schemas.openxmlformats.org/drawingml/2006/main">
             <a:pPr>
+              <a:buNone/>
               <a:defRPr sz="1200" b="0">
                 <a:solidFill>
                   <a:srgbClr val="577068"/>
@@ -38717,7 +38837,7 @@
                 <a:ea typeface="DejaVu Sans"/>
                 <a:cs typeface="DejaVu Sans"/>
               </a:rPr>
-              <a:t>rsn habit calendar one b 1.1.3</a:t>
+              <a:t>rsn habit calendar one b 1.1.4</a:t>
             </a:r>
           </a:p>
         </p:txBody>
@@ -38763,6 +38883,7 @@
               </a:defRPr>
             </a:defPPr>
             <a:lvl1pPr>
+              <a:buNone/>
               <a:defRPr sz="1350" b="0">
                 <a:solidFill>
                   <a:srgbClr val="577068"/>
@@ -38773,6 +38894,7 @@
               </a:defRPr>
             </a:lvl1pPr>
             <a:lvl2pPr>
+              <a:buNone/>
               <a:defRPr sz="1350" b="0">
                 <a:solidFill>
                   <a:srgbClr val="577068"/>
@@ -38783,6 +38905,7 @@
               </a:defRPr>
             </a:lvl2pPr>
             <a:lvl3pPr>
+              <a:buNone/>
               <a:defRPr sz="1350" b="0">
                 <a:solidFill>
                   <a:srgbClr val="577068"/>
@@ -38793,6 +38916,7 @@
               </a:defRPr>
             </a:lvl3pPr>
             <a:lvl4pPr>
+              <a:buNone/>
               <a:defRPr sz="1350" b="0">
                 <a:solidFill>
                   <a:srgbClr val="577068"/>
@@ -38803,6 +38927,7 @@
               </a:defRPr>
             </a:lvl4pPr>
             <a:lvl5pPr>
+              <a:buNone/>
               <a:defRPr sz="1350" b="0">
                 <a:solidFill>
                   <a:srgbClr val="577068"/>
@@ -38813,6 +38938,7 @@
               </a:defRPr>
             </a:lvl5pPr>
             <a:lvl6pPr>
+              <a:buNone/>
               <a:defRPr sz="1350" b="0">
                 <a:solidFill>
                   <a:srgbClr val="577068"/>
@@ -38823,6 +38949,7 @@
               </a:defRPr>
             </a:lvl6pPr>
             <a:lvl7pPr>
+              <a:buNone/>
               <a:defRPr sz="1350" b="0">
                 <a:solidFill>
                   <a:srgbClr val="577068"/>
@@ -38833,6 +38960,7 @@
               </a:defRPr>
             </a:lvl7pPr>
             <a:lvl8pPr>
+              <a:buNone/>
               <a:defRPr sz="1350" b="0">
                 <a:solidFill>
                   <a:srgbClr val="577068"/>
@@ -38843,6 +38971,7 @@
               </a:defRPr>
             </a:lvl8pPr>
             <a:lvl9pPr>
+              <a:buNone/>
               <a:defRPr sz="1350" b="0">
                 <a:solidFill>
                   <a:srgbClr val="577068"/>
@@ -38855,6 +38984,7 @@
           </a:lstStyle>
           <a:p xmlns:a="http://schemas.openxmlformats.org/drawingml/2006/main">
             <a:pPr>
+              <a:buNone/>
               <a:defRPr sz="1350" b="0">
                 <a:solidFill>
                   <a:srgbClr val="577068"/>
@@ -39898,7 +40028,7 @@
                 <a:ea typeface="DejaVu Sans"/>
                 <a:cs typeface="DejaVu Sans"/>
               </a:rPr>
-              <a:t>rsn habit calendar one b 1.1.3</a:t>
+              <a:t>rsn habit calendar one b 1.1.4</a:t>
             </a:r>
           </a:p>
         </p:txBody>
@@ -40757,7 +40887,7 @@
                 <a:ea typeface="DejaVu Sans"/>
                 <a:cs typeface="DejaVu Sans"/>
               </a:rPr>
-              <a:t>Attach each of the six release-assets files separately to tag 1.1.3.</a:t>
+              <a:t>Attach each of the six release-assets files separately to tag 1.1.4.</a:t>
             </a:r>
           </a:p>
         </p:txBody>
@@ -41089,7 +41219,7 @@
                 <a:ea typeface="DejaVu Sans"/>
                 <a:cs typeface="DejaVu Sans"/>
               </a:rPr>
-              <a:t>rsn habit calendar one b 1.1.3</a:t>
+              <a:t>rsn habit calendar one b 1.1.4</a:t>
             </a:r>
           </a:p>
         </p:txBody>
@@ -41450,7 +41580,7 @@
                 <a:ea typeface="DejaVu Sans"/>
                 <a:cs typeface="DejaVu Sans"/>
               </a:rPr>
-              <a:t>Maintainer: acceptance tests</a:t>
+              <a:t>Maintainer: build and device tests</a:t>
             </a:r>
           </a:p>
         </p:txBody>
@@ -41616,7 +41746,7 @@
                 <a:ea typeface="DejaVu Sans"/>
                 <a:cs typeface="DejaVu Sans"/>
               </a:rPr>
-              <a:t>Run npm ci --ignore-scripts, npm run check and npm run test:helper.</a:t>
+              <a:t>Run node scripts/check-lockfile.mjs, then npm ci --ignore-scripts.</a:t>
             </a:r>
           </a:p>
         </p:txBody>
@@ -41782,7 +41912,7 @@
                 <a:ea typeface="DejaVu Sans"/>
                 <a:cs typeface="DejaVu Sans"/>
               </a:rPr>
-              <a:t>Wait for Ubuntu, Windows and macOS GitHub Actions jobs to pass.</a:t>
+              <a:t>Run npm run check and npm run test:helper. Use Node.js 22+ and Python.</a:t>
             </a:r>
           </a:p>
         </p:txBody>
@@ -41948,7 +42078,7 @@
                 <a:ea typeface="DejaVu Sans"/>
                 <a:cs typeface="DejaVu Sans"/>
               </a:rPr>
-              <a:t>Download the release. Test fresh installation and migration from the old identity.</a:t>
+              <a:t>Push the repaired source. Wait for Ubuntu, Windows and macOS CI to pass.</a:t>
             </a:r>
           </a:p>
         </p:txBody>
@@ -42114,7 +42244,7 @@
                 <a:ea typeface="DejaVu Sans"/>
                 <a:cs typeface="DejaVu Sans"/>
               </a:rPr>
-              <a:t>Record exact device/app versions and outcomes in TEST-RESULTS-TEMPLATE.md.</a:t>
+              <a:t>Test downloaded assets in Obsidian and record exact OS/app versions.</a:t>
             </a:r>
           </a:p>
         </p:txBody>
@@ -42280,7 +42410,7 @@
                 <a:ea typeface="DejaVu Sans"/>
                 <a:cs typeface="DejaVu Sans"/>
               </a:rPr>
-              <a:t>rsn habit calendar one b 1.1.3</a:t>
+              <a:t>rsn habit calendar one b 1.1.4</a:t>
             </a:r>
           </a:p>
         </p:txBody>
@@ -42807,7 +42937,7 @@
                 <a:ea typeface="DejaVu Sans"/>
                 <a:cs typeface="DejaVu Sans"/>
               </a:rPr>
-              <a:t>Commit manifest.json with the new ID, exact requested name and version 1.1.3.</a:t>
+              <a:t>Commit manifest.json with the new ID, exact requested name and version 1.1.4.</a:t>
             </a:r>
           </a:p>
         </p:txBody>
@@ -42973,7 +43103,7 @@
                 <a:ea typeface="DejaVu Sans"/>
                 <a:cs typeface="DejaVu Sans"/>
               </a:rPr>
-              <a:t>Publish tag 1.1.3 with main.js, manifest.json and styles.css attached individually.</a:t>
+              <a:t>Publish tag 1.1.4 with main.js, manifest.json and styles.css attached individually.</a:t>
             </a:r>
           </a:p>
         </p:txBody>
@@ -43471,7 +43601,7 @@
                 <a:ea typeface="DejaVu Sans"/>
                 <a:cs typeface="DejaVu Sans"/>
               </a:rPr>
-              <a:t>rsn habit calendar one b 1.1.3</a:t>
+              <a:t>rsn habit calendar one b 1.1.4</a:t>
             </a:r>
           </a:p>
         </p:txBody>
@@ -43832,7 +43962,7 @@
                 <a:ea typeface="DejaVu Sans"/>
                 <a:cs typeface="DejaVu Sans"/>
               </a:rPr>
-              <a:t>Maintainer: review and updates</a:t>
+              <a:t>Fixing the npm download failure</a:t>
             </a:r>
           </a:p>
         </p:txBody>
@@ -43998,7 +44128,7 @@
                 <a:ea typeface="DejaVu Sans"/>
                 <a:cs typeface="DejaVu Sans"/>
               </a:rPr>
-              <a:t>The directory checks manifest, release assets, source and build verification.</a:t>
+              <a:t>All three reported jobs fetched unavailable which-typed-array 1.1.34.</a:t>
             </a:r>
           </a:p>
         </p:txBody>
@@ -44164,7 +44294,7 @@
                 <a:ea typeface="DejaVu Sans"/>
                 <a:cs typeface="DejaVu Sans"/>
               </a:rPr>
-              <a:t>Use Review branch for a preview scan when the entry management page offers it.</a:t>
+              <a:t>Upload the repaired root package-lock.json; it resolves version 1.1.24.</a:t>
             </a:r>
           </a:p>
         </p:txBody>
@@ -44330,7 +44460,7 @@
                 <a:ea typeface="DejaVu Sans"/>
                 <a:cs typeface="DejaVu Sans"/>
               </a:rPr>
-              <a:t>Fix issues in a new version and release. Local lint does not grant acceptance.</a:t>
+              <a:t>Run the NEW commit. Re-running the old job reuses its old source.</a:t>
             </a:r>
           </a:p>
         </p:txBody>
@@ -44496,7 +44626,7 @@
                 <a:ea typeface="DejaVu Sans"/>
                 <a:cs typeface="DejaVu Sans"/>
               </a:rPr>
-              <a:t>For future versions, publish matching release assets and monitor new review results.</a:t>
+              <a:t>Check the preflight commit and lockfile digest in every operating-system job.</a:t>
             </a:r>
           </a:p>
         </p:txBody>
@@ -44662,7 +44792,7 @@
                 <a:ea typeface="DejaVu Sans"/>
                 <a:cs typeface="DejaVu Sans"/>
               </a:rPr>
-              <a:t>rsn habit calendar one b 1.1.3</a:t>
+              <a:t>rsn habit calendar one b 1.1.4</a:t>
             </a:r>
           </a:p>
         </p:txBody>
@@ -45033,7 +45163,7 @@
           <p:cNvPr id="2" name="">
             <a:extLst xmlns:a="http://schemas.openxmlformats.org/drawingml/2006/main">
               <a:ext uri="{FF2B5EF4-FFF2-40B4-BE49-F238E27FC236}">
-                <a16:creationId xmlns:a16="http://schemas.microsoft.com/office/drawing/2014/main" id="{93EB97B4-6FEF-42D5-B6DC-30BD1CEAF6F3}"/>
+                <a16:creationId xmlns:a16="http://schemas.microsoft.com/office/drawing/2014/main" id="{AB614267-A876-46FD-9C91-E8934C720A88}"/>
               </a:ext>
             </a:extLst>
           </p:cNvPr>
@@ -45043,7 +45173,7 @@
           <p:nvPr/>
         </p:nvPicPr>
         <p:blipFill>
-          <a:blip xmlns:r="http://schemas.openxmlformats.org/officeDocument/2006/relationships" xmlns:a="http://schemas.openxmlformats.org/drawingml/2006/main" r:embed="Rbfd6987ee2ec446f"/>
+          <a:blip xmlns:r="http://schemas.openxmlformats.org/officeDocument/2006/relationships" xmlns:a="http://schemas.openxmlformats.org/drawingml/2006/main" r:embed="R46d05dc40eb443e3"/>
           <a:stretch xmlns:a="http://schemas.openxmlformats.org/drawingml/2006/main"/>
         </p:blipFill>
         <p:spPr>
@@ -47072,7 +47202,7 @@
                 <a:ea typeface="DejaVu Sans"/>
                 <a:cs typeface="DejaVu Sans"/>
               </a:rPr>
-              <a:t>rsn habit calendar one b 1.1.3</a:t>
+              <a:t>rsn habit calendar one b 1.1.4</a:t>
             </a:r>
           </a:p>
         </p:txBody>
@@ -48263,7 +48393,7 @@
                 <a:ea typeface="DejaVu Sans"/>
                 <a:cs typeface="DejaVu Sans"/>
               </a:rPr>
-              <a:t>rsn habit calendar one b 1.1.3</a:t>
+              <a:t>rsn habit calendar one b 1.1.4</a:t>
             </a:r>
           </a:p>
         </p:txBody>
@@ -48956,7 +49086,7 @@
                 <a:ea typeface="DejaVu Sans"/>
                 <a:cs typeface="DejaVu Sans"/>
               </a:rPr>
-              <a:t>Select release tag 1.1.3 and expand Assets.</a:t>
+              <a:t>Select release tag 1.1.4 and expand Assets.</a:t>
             </a:r>
           </a:p>
         </p:txBody>
@@ -49454,7 +49584,7 @@
                 <a:ea typeface="DejaVu Sans"/>
                 <a:cs typeface="DejaVu Sans"/>
               </a:rPr>
-              <a:t>rsn habit calendar one b 1.1.3</a:t>
+              <a:t>rsn habit calendar one b 1.1.4</a:t>
             </a:r>
           </a:p>
         </p:txBody>
@@ -50645,7 +50775,7 @@
                 <a:ea typeface="DejaVu Sans"/>
                 <a:cs typeface="DejaVu Sans"/>
               </a:rPr>
-              <a:t>rsn habit calendar one b 1.1.3</a:t>
+              <a:t>rsn habit calendar one b 1.1.4</a:t>
             </a:r>
           </a:p>
         </p:txBody>
@@ -51836,7 +51966,7 @@
                 <a:ea typeface="DejaVu Sans"/>
                 <a:cs typeface="DejaVu Sans"/>
               </a:rPr>
-              <a:t>rsn habit calendar one b 1.1.3</a:t>
+              <a:t>rsn habit calendar one b 1.1.4</a:t>
             </a:r>
           </a:p>
         </p:txBody>
@@ -53027,7 +53157,7 @@
                 <a:ea typeface="DejaVu Sans"/>
                 <a:cs typeface="DejaVu Sans"/>
               </a:rPr>
-              <a:t>rsn habit calendar one b 1.1.3</a:t>
+              <a:t>rsn habit calendar one b 1.1.4</a:t>
             </a:r>
           </a:p>
         </p:txBody>

</xml_diff>